<commit_message>
Add Per-class Top-4 Accuracy slide (slide 5) to 10-class PPT
Insert new slide after Top-1 table with identical layout showing
Top-4 accuracy per class + Overall row. Color coding: red=0%,
green>=80%, orange=mid-range. Total slides: 6→7.

Co-Authored-By: Claude Opus 4.6 (1M context) <noreply@anthropic.com>
</commit_message>
<xml_diff>
--- a/outputs/presentations/10class_comparison.pptx
+++ b/outputs/presentations/10class_comparison.pptx
@@ -11,6 +11,7 @@
     <p:sldId id="259" r:id="rId10"/>
     <p:sldId id="260" r:id="rId11"/>
     <p:sldId id="261" r:id="rId12"/>
+    <p:sldId id="262" r:id="rId13"/>
   </p:sldIdLst>
   <p:sldSz cx="12191695" cy="6858000" type="screen4x3"/>
   <p:notesSz cx="6858000" cy="9144000"/>
@@ -7535,6 +7536,2401 @@
                 </a:solidFill>
                 <a:latin typeface="맑은 고딕"/>
               </a:rPr>
+              <a:t>Per-class Top-4 Accuracy (%)</a:t>
+            </a:r>
+          </a:p>
+        </p:txBody>
+      </p:sp>
+      <p:graphicFrame>
+        <p:nvGraphicFramePr>
+          <p:cNvPr id="4" name="Table 3"/>
+          <p:cNvGraphicFramePr>
+            <a:graphicFrameLocks noGrp="1"/>
+          </p:cNvGraphicFramePr>
+          <p:nvPr/>
+        </p:nvGraphicFramePr>
+        <p:xfrm>
+          <a:off x="472287.5" y="1005840"/>
+          <a:ext cx="10607040" cy="5303520"/>
+        </p:xfrm>
+        <a:graphic>
+          <a:graphicData uri="http://schemas.openxmlformats.org/drawingml/2006/table">
+            <a:tbl>
+              <a:tblPr firstRow="1" bandRow="1">
+                <a:tableStyleId>{5C22544A-7EE6-4342-B048-85BDC9FD1C3A}</a:tableStyleId>
+              </a:tblPr>
+              <a:tblGrid>
+                <a:gridCol w="1371600"/>
+                <a:gridCol w="914400"/>
+                <a:gridCol w="1097280"/>
+                <a:gridCol w="1097280"/>
+                <a:gridCol w="1371600"/>
+                <a:gridCol w="1463040"/>
+                <a:gridCol w="1463040"/>
+                <a:gridCol w="1828800"/>
+              </a:tblGrid>
+              <a:tr h="441960">
+                <a:tc>
+                  <a:txBody>
+                    <a:bodyPr/>
+                    <a:lstStyle/>
+                    <a:p>
+                      <a:pPr algn="ctr"/>
+                      <a:r>
+                        <a:rPr sz="1400" b="1">
+                          <a:solidFill>
+                            <a:srgbClr val="FFFFFF"/>
+                          </a:solidFill>
+                          <a:latin typeface="맑은 고딕"/>
+                        </a:rPr>
+                        <a:t>클래스</a:t>
+                      </a:r>
+                    </a:p>
+                  </a:txBody>
+                  <a:tcPr>
+                    <a:solidFill>
+                      <a:srgbClr val="2980B9"/>
+                    </a:solidFill>
+                  </a:tcPr>
+                </a:tc>
+                <a:tc>
+                  <a:txBody>
+                    <a:bodyPr/>
+                    <a:lstStyle/>
+                    <a:p>
+                      <a:pPr algn="ctr"/>
+                      <a:r>
+                        <a:rPr sz="1400" b="1">
+                          <a:solidFill>
+                            <a:srgbClr val="FFFFFF"/>
+                          </a:solidFill>
+                          <a:latin typeface="맑은 고딕"/>
+                        </a:rPr>
+                        <a:t>비율</a:t>
+                      </a:r>
+                    </a:p>
+                  </a:txBody>
+                  <a:tcPr>
+                    <a:solidFill>
+                      <a:srgbClr val="2980B9"/>
+                    </a:solidFill>
+                  </a:tcPr>
+                </a:tc>
+                <a:tc>
+                  <a:txBody>
+                    <a:bodyPr/>
+                    <a:lstStyle/>
+                    <a:p>
+                      <a:pPr algn="ctr"/>
+                      <a:r>
+                        <a:rPr sz="1400" b="1">
+                          <a:solidFill>
+                            <a:srgbClr val="FFFFFF"/>
+                          </a:solidFill>
+                          <a:latin typeface="맑은 고딕"/>
+                        </a:rPr>
+                        <a:t>LR</a:t>
+                      </a:r>
+                    </a:p>
+                  </a:txBody>
+                  <a:tcPr>
+                    <a:solidFill>
+                      <a:srgbClr val="2980B9"/>
+                    </a:solidFill>
+                  </a:tcPr>
+                </a:tc>
+                <a:tc>
+                  <a:txBody>
+                    <a:bodyPr/>
+                    <a:lstStyle/>
+                    <a:p>
+                      <a:pPr algn="ctr"/>
+                      <a:r>
+                        <a:rPr sz="1400" b="1">
+                          <a:solidFill>
+                            <a:srgbClr val="FFFFFF"/>
+                          </a:solidFill>
+                          <a:latin typeface="맑은 고딕"/>
+                        </a:rPr>
+                        <a:t>LGB</a:t>
+                      </a:r>
+                    </a:p>
+                  </a:txBody>
+                  <a:tcPr>
+                    <a:solidFill>
+                      <a:srgbClr val="2980B9"/>
+                    </a:solidFill>
+                  </a:tcPr>
+                </a:tc>
+                <a:tc>
+                  <a:txBody>
+                    <a:bodyPr/>
+                    <a:lstStyle/>
+                    <a:p>
+                      <a:pPr algn="ctr"/>
+                      <a:r>
+                        <a:rPr sz="1400" b="1">
+                          <a:solidFill>
+                            <a:srgbClr val="FFFFFF"/>
+                          </a:solidFill>
+                          <a:latin typeface="맑은 고딕"/>
+                        </a:rPr>
+                        <a:t>MLP 77d</a:t>
+                      </a:r>
+                    </a:p>
+                  </a:txBody>
+                  <a:tcPr>
+                    <a:solidFill>
+                      <a:srgbClr val="2980B9"/>
+                    </a:solidFill>
+                  </a:tcPr>
+                </a:tc>
+                <a:tc>
+                  <a:txBody>
+                    <a:bodyPr/>
+                    <a:lstStyle/>
+                    <a:p>
+                      <a:pPr algn="ctr"/>
+                      <a:r>
+                        <a:rPr sz="1400" b="1">
+                          <a:solidFill>
+                            <a:srgbClr val="FFFFFF"/>
+                          </a:solidFill>
+                          <a:latin typeface="맑은 고딕"/>
+                        </a:rPr>
+                        <a:t>MLP 135d</a:t>
+                      </a:r>
+                    </a:p>
+                  </a:txBody>
+                  <a:tcPr>
+                    <a:solidFill>
+                      <a:srgbClr val="2980B9"/>
+                    </a:solidFill>
+                  </a:tcPr>
+                </a:tc>
+                <a:tc>
+                  <a:txBody>
+                    <a:bodyPr/>
+                    <a:lstStyle/>
+                    <a:p>
+                      <a:pPr algn="ctr"/>
+                      <a:r>
+                        <a:rPr sz="1400" b="1">
+                          <a:solidFill>
+                            <a:srgbClr val="FFFFFF"/>
+                          </a:solidFill>
+                          <a:latin typeface="맑은 고딕"/>
+                        </a:rPr>
+                        <a:t>RNN</a:t>
+                      </a:r>
+                    </a:p>
+                  </a:txBody>
+                  <a:tcPr>
+                    <a:solidFill>
+                      <a:srgbClr val="2980B9"/>
+                    </a:solidFill>
+                  </a:tcPr>
+                </a:tc>
+                <a:tc>
+                  <a:txBody>
+                    <a:bodyPr/>
+                    <a:lstStyle/>
+                    <a:p>
+                      <a:pPr algn="ctr"/>
+                      <a:r>
+                        <a:rPr sz="1400" b="1">
+                          <a:solidFill>
+                            <a:srgbClr val="FFFFFF"/>
+                          </a:solidFill>
+                          <a:latin typeface="맑은 고딕"/>
+                        </a:rPr>
+                        <a:t>Transformer</a:t>
+                      </a:r>
+                    </a:p>
+                  </a:txBody>
+                  <a:tcPr>
+                    <a:solidFill>
+                      <a:srgbClr val="2980B9"/>
+                    </a:solidFill>
+                  </a:tcPr>
+                </a:tc>
+              </a:tr>
+              <a:tr h="441960">
+                <a:tc>
+                  <a:txBody>
+                    <a:bodyPr/>
+                    <a:lstStyle/>
+                    <a:p>
+                      <a:pPr algn="ctr"/>
+                      <a:r>
+                        <a:rPr sz="1400" b="0">
+                          <a:solidFill>
+                            <a:srgbClr val="2C3E50"/>
+                          </a:solidFill>
+                          <a:latin typeface="맑은 고딕"/>
+                        </a:rPr>
+                        <a:t>Ball</a:t>
+                      </a:r>
+                    </a:p>
+                  </a:txBody>
+                  <a:tcPr>
+                    <a:solidFill>
+                      <a:srgbClr val="FFFFFF"/>
+                    </a:solidFill>
+                  </a:tcPr>
+                </a:tc>
+                <a:tc>
+                  <a:txBody>
+                    <a:bodyPr/>
+                    <a:lstStyle/>
+                    <a:p>
+                      <a:pPr algn="ctr"/>
+                      <a:r>
+                        <a:rPr sz="1400" b="0">
+                          <a:solidFill>
+                            <a:srgbClr val="2C3E50"/>
+                          </a:solidFill>
+                          <a:latin typeface="맑은 고딕"/>
+                        </a:rPr>
+                        <a:t>33.3%</a:t>
+                      </a:r>
+                    </a:p>
+                  </a:txBody>
+                  <a:tcPr>
+                    <a:solidFill>
+                      <a:srgbClr val="FFFFFF"/>
+                    </a:solidFill>
+                  </a:tcPr>
+                </a:tc>
+                <a:tc>
+                  <a:txBody>
+                    <a:bodyPr/>
+                    <a:lstStyle/>
+                    <a:p>
+                      <a:pPr algn="ctr"/>
+                      <a:r>
+                        <a:rPr sz="1400" b="0">
+                          <a:solidFill>
+                            <a:srgbClr val="2C3E50"/>
+                          </a:solidFill>
+                          <a:latin typeface="맑은 고딕"/>
+                        </a:rPr>
+                        <a:t>100</a:t>
+                      </a:r>
+                    </a:p>
+                  </a:txBody>
+                  <a:tcPr>
+                    <a:solidFill>
+                      <a:srgbClr val="FFFFFF"/>
+                    </a:solidFill>
+                  </a:tcPr>
+                </a:tc>
+                <a:tc>
+                  <a:txBody>
+                    <a:bodyPr/>
+                    <a:lstStyle/>
+                    <a:p>
+                      <a:pPr algn="ctr"/>
+                      <a:r>
+                        <a:rPr sz="1400" b="0">
+                          <a:solidFill>
+                            <a:srgbClr val="2C3E50"/>
+                          </a:solidFill>
+                          <a:latin typeface="맑은 고딕"/>
+                        </a:rPr>
+                        <a:t>70.6</a:t>
+                      </a:r>
+                    </a:p>
+                  </a:txBody>
+                  <a:tcPr>
+                    <a:solidFill>
+                      <a:srgbClr val="FFFFFF"/>
+                    </a:solidFill>
+                  </a:tcPr>
+                </a:tc>
+                <a:tc>
+                  <a:txBody>
+                    <a:bodyPr/>
+                    <a:lstStyle/>
+                    <a:p>
+                      <a:pPr algn="ctr"/>
+                      <a:r>
+                        <a:rPr sz="1400" b="0">
+                          <a:solidFill>
+                            <a:srgbClr val="2C3E50"/>
+                          </a:solidFill>
+                          <a:latin typeface="맑은 고딕"/>
+                        </a:rPr>
+                        <a:t>100</a:t>
+                      </a:r>
+                    </a:p>
+                  </a:txBody>
+                  <a:tcPr>
+                    <a:solidFill>
+                      <a:srgbClr val="FFFFFF"/>
+                    </a:solidFill>
+                  </a:tcPr>
+                </a:tc>
+                <a:tc>
+                  <a:txBody>
+                    <a:bodyPr/>
+                    <a:lstStyle/>
+                    <a:p>
+                      <a:pPr algn="ctr"/>
+                      <a:r>
+                        <a:rPr sz="1400" b="0">
+                          <a:solidFill>
+                            <a:srgbClr val="2C3E50"/>
+                          </a:solidFill>
+                          <a:latin typeface="맑은 고딕"/>
+                        </a:rPr>
+                        <a:t>99.6</a:t>
+                      </a:r>
+                    </a:p>
+                  </a:txBody>
+                  <a:tcPr>
+                    <a:solidFill>
+                      <a:srgbClr val="D5F5E3"/>
+                    </a:solidFill>
+                  </a:tcPr>
+                </a:tc>
+                <a:tc>
+                  <a:txBody>
+                    <a:bodyPr/>
+                    <a:lstStyle/>
+                    <a:p>
+                      <a:pPr algn="ctr"/>
+                      <a:r>
+                        <a:rPr sz="1400" b="0">
+                          <a:solidFill>
+                            <a:srgbClr val="2C3E50"/>
+                          </a:solidFill>
+                          <a:latin typeface="맑은 고딕"/>
+                        </a:rPr>
+                        <a:t>99.4</a:t>
+                      </a:r>
+                    </a:p>
+                  </a:txBody>
+                  <a:tcPr>
+                    <a:solidFill>
+                      <a:srgbClr val="D5F5E3"/>
+                    </a:solidFill>
+                  </a:tcPr>
+                </a:tc>
+                <a:tc>
+                  <a:txBody>
+                    <a:bodyPr/>
+                    <a:lstStyle/>
+                    <a:p>
+                      <a:pPr algn="ctr"/>
+                      <a:r>
+                        <a:rPr sz="1400" b="0">
+                          <a:solidFill>
+                            <a:srgbClr val="2C3E50"/>
+                          </a:solidFill>
+                          <a:latin typeface="맑은 고딕"/>
+                        </a:rPr>
+                        <a:t>99.6</a:t>
+                      </a:r>
+                    </a:p>
+                  </a:txBody>
+                  <a:tcPr>
+                    <a:solidFill>
+                      <a:srgbClr val="D5F5E3"/>
+                    </a:solidFill>
+                  </a:tcPr>
+                </a:tc>
+              </a:tr>
+              <a:tr h="441960">
+                <a:tc>
+                  <a:txBody>
+                    <a:bodyPr/>
+                    <a:lstStyle/>
+                    <a:p>
+                      <a:pPr algn="ctr"/>
+                      <a:r>
+                        <a:rPr sz="1400" b="0">
+                          <a:solidFill>
+                            <a:srgbClr val="2C3E50"/>
+                          </a:solidFill>
+                          <a:latin typeface="맑은 고딕"/>
+                        </a:rPr>
+                        <a:t>Strike</a:t>
+                      </a:r>
+                    </a:p>
+                  </a:txBody>
+                  <a:tcPr>
+                    <a:solidFill>
+                      <a:srgbClr val="FFFFFF"/>
+                    </a:solidFill>
+                  </a:tcPr>
+                </a:tc>
+                <a:tc>
+                  <a:txBody>
+                    <a:bodyPr/>
+                    <a:lstStyle/>
+                    <a:p>
+                      <a:pPr algn="ctr"/>
+                      <a:r>
+                        <a:rPr sz="1400" b="0">
+                          <a:solidFill>
+                            <a:srgbClr val="2C3E50"/>
+                          </a:solidFill>
+                          <a:latin typeface="맑은 고딕"/>
+                        </a:rPr>
+                        <a:t>41.1%</a:t>
+                      </a:r>
+                    </a:p>
+                  </a:txBody>
+                  <a:tcPr>
+                    <a:solidFill>
+                      <a:srgbClr val="FFFFFF"/>
+                    </a:solidFill>
+                  </a:tcPr>
+                </a:tc>
+                <a:tc>
+                  <a:txBody>
+                    <a:bodyPr/>
+                    <a:lstStyle/>
+                    <a:p>
+                      <a:pPr algn="ctr"/>
+                      <a:r>
+                        <a:rPr sz="1400" b="0">
+                          <a:solidFill>
+                            <a:srgbClr val="2C3E50"/>
+                          </a:solidFill>
+                          <a:latin typeface="맑은 고딕"/>
+                        </a:rPr>
+                        <a:t>100</a:t>
+                      </a:r>
+                    </a:p>
+                  </a:txBody>
+                  <a:tcPr>
+                    <a:solidFill>
+                      <a:srgbClr val="FFFFFF"/>
+                    </a:solidFill>
+                  </a:tcPr>
+                </a:tc>
+                <a:tc>
+                  <a:txBody>
+                    <a:bodyPr/>
+                    <a:lstStyle/>
+                    <a:p>
+                      <a:pPr algn="ctr"/>
+                      <a:r>
+                        <a:rPr sz="1400" b="0">
+                          <a:solidFill>
+                            <a:srgbClr val="2C3E50"/>
+                          </a:solidFill>
+                          <a:latin typeface="맑은 고딕"/>
+                        </a:rPr>
+                        <a:t>70.4</a:t>
+                      </a:r>
+                    </a:p>
+                  </a:txBody>
+                  <a:tcPr>
+                    <a:solidFill>
+                      <a:srgbClr val="FFFFFF"/>
+                    </a:solidFill>
+                  </a:tcPr>
+                </a:tc>
+                <a:tc>
+                  <a:txBody>
+                    <a:bodyPr/>
+                    <a:lstStyle/>
+                    <a:p>
+                      <a:pPr algn="ctr"/>
+                      <a:r>
+                        <a:rPr sz="1400" b="0">
+                          <a:solidFill>
+                            <a:srgbClr val="2C3E50"/>
+                          </a:solidFill>
+                          <a:latin typeface="맑은 고딕"/>
+                        </a:rPr>
+                        <a:t>100</a:t>
+                      </a:r>
+                    </a:p>
+                  </a:txBody>
+                  <a:tcPr>
+                    <a:solidFill>
+                      <a:srgbClr val="FFFFFF"/>
+                    </a:solidFill>
+                  </a:tcPr>
+                </a:tc>
+                <a:tc>
+                  <a:txBody>
+                    <a:bodyPr/>
+                    <a:lstStyle/>
+                    <a:p>
+                      <a:pPr algn="ctr"/>
+                      <a:r>
+                        <a:rPr sz="1400" b="0">
+                          <a:solidFill>
+                            <a:srgbClr val="2C3E50"/>
+                          </a:solidFill>
+                          <a:latin typeface="맑은 고딕"/>
+                        </a:rPr>
+                        <a:t>100</a:t>
+                      </a:r>
+                    </a:p>
+                  </a:txBody>
+                  <a:tcPr>
+                    <a:solidFill>
+                      <a:srgbClr val="D5F5E3"/>
+                    </a:solidFill>
+                  </a:tcPr>
+                </a:tc>
+                <a:tc>
+                  <a:txBody>
+                    <a:bodyPr/>
+                    <a:lstStyle/>
+                    <a:p>
+                      <a:pPr algn="ctr"/>
+                      <a:r>
+                        <a:rPr sz="1400" b="0">
+                          <a:solidFill>
+                            <a:srgbClr val="2C3E50"/>
+                          </a:solidFill>
+                          <a:latin typeface="맑은 고딕"/>
+                        </a:rPr>
+                        <a:t>100</a:t>
+                      </a:r>
+                    </a:p>
+                  </a:txBody>
+                  <a:tcPr>
+                    <a:solidFill>
+                      <a:srgbClr val="D5F5E3"/>
+                    </a:solidFill>
+                  </a:tcPr>
+                </a:tc>
+                <a:tc>
+                  <a:txBody>
+                    <a:bodyPr/>
+                    <a:lstStyle/>
+                    <a:p>
+                      <a:pPr algn="ctr"/>
+                      <a:r>
+                        <a:rPr sz="1400" b="0">
+                          <a:solidFill>
+                            <a:srgbClr val="2C3E50"/>
+                          </a:solidFill>
+                          <a:latin typeface="맑은 고딕"/>
+                        </a:rPr>
+                        <a:t>100</a:t>
+                      </a:r>
+                    </a:p>
+                  </a:txBody>
+                  <a:tcPr>
+                    <a:solidFill>
+                      <a:srgbClr val="D5F5E3"/>
+                    </a:solidFill>
+                  </a:tcPr>
+                </a:tc>
+              </a:tr>
+              <a:tr h="441960">
+                <a:tc>
+                  <a:txBody>
+                    <a:bodyPr/>
+                    <a:lstStyle/>
+                    <a:p>
+                      <a:pPr algn="ctr"/>
+                      <a:r>
+                        <a:rPr sz="1400" b="0">
+                          <a:solidFill>
+                            <a:srgbClr val="2C3E50"/>
+                          </a:solidFill>
+                          <a:latin typeface="맑은 고딕"/>
+                        </a:rPr>
+                        <a:t>Single</a:t>
+                      </a:r>
+                    </a:p>
+                  </a:txBody>
+                  <a:tcPr>
+                    <a:solidFill>
+                      <a:srgbClr val="FFFFFF"/>
+                    </a:solidFill>
+                  </a:tcPr>
+                </a:tc>
+                <a:tc>
+                  <a:txBody>
+                    <a:bodyPr/>
+                    <a:lstStyle/>
+                    <a:p>
+                      <a:pPr algn="ctr"/>
+                      <a:r>
+                        <a:rPr sz="1400" b="0">
+                          <a:solidFill>
+                            <a:srgbClr val="2C3E50"/>
+                          </a:solidFill>
+                          <a:latin typeface="맑은 고딕"/>
+                        </a:rPr>
+                        <a:t>3.6%</a:t>
+                      </a:r>
+                    </a:p>
+                  </a:txBody>
+                  <a:tcPr>
+                    <a:solidFill>
+                      <a:srgbClr val="FFFFFF"/>
+                    </a:solidFill>
+                  </a:tcPr>
+                </a:tc>
+                <a:tc>
+                  <a:txBody>
+                    <a:bodyPr/>
+                    <a:lstStyle/>
+                    <a:p>
+                      <a:pPr algn="ctr"/>
+                      <a:r>
+                        <a:rPr sz="1400" b="0">
+                          <a:solidFill>
+                            <a:srgbClr val="2C3E50"/>
+                          </a:solidFill>
+                          <a:latin typeface="맑은 고딕"/>
+                        </a:rPr>
+                        <a:t>0.2</a:t>
+                      </a:r>
+                    </a:p>
+                  </a:txBody>
+                  <a:tcPr>
+                    <a:solidFill>
+                      <a:srgbClr val="FFFFFF"/>
+                    </a:solidFill>
+                  </a:tcPr>
+                </a:tc>
+                <a:tc>
+                  <a:txBody>
+                    <a:bodyPr/>
+                    <a:lstStyle/>
+                    <a:p>
+                      <a:pPr algn="ctr"/>
+                      <a:r>
+                        <a:rPr sz="1400" b="0">
+                          <a:solidFill>
+                            <a:srgbClr val="2C3E50"/>
+                          </a:solidFill>
+                          <a:latin typeface="맑은 고딕"/>
+                        </a:rPr>
+                        <a:t>47.8</a:t>
+                      </a:r>
+                    </a:p>
+                  </a:txBody>
+                  <a:tcPr>
+                    <a:solidFill>
+                      <a:srgbClr val="FFFFFF"/>
+                    </a:solidFill>
+                  </a:tcPr>
+                </a:tc>
+                <a:tc>
+                  <a:txBody>
+                    <a:bodyPr/>
+                    <a:lstStyle/>
+                    <a:p>
+                      <a:pPr algn="ctr"/>
+                      <a:r>
+                        <a:rPr sz="1400" b="0">
+                          <a:solidFill>
+                            <a:srgbClr val="2C3E50"/>
+                          </a:solidFill>
+                          <a:latin typeface="맑은 고딕"/>
+                        </a:rPr>
+                        <a:t>0</a:t>
+                      </a:r>
+                    </a:p>
+                  </a:txBody>
+                  <a:tcPr>
+                    <a:solidFill>
+                      <a:srgbClr val="FDEDED"/>
+                    </a:solidFill>
+                  </a:tcPr>
+                </a:tc>
+                <a:tc>
+                  <a:txBody>
+                    <a:bodyPr/>
+                    <a:lstStyle/>
+                    <a:p>
+                      <a:pPr algn="ctr"/>
+                      <a:r>
+                        <a:rPr sz="1400" b="0">
+                          <a:solidFill>
+                            <a:srgbClr val="2C3E50"/>
+                          </a:solidFill>
+                          <a:latin typeface="맑은 고딕"/>
+                        </a:rPr>
+                        <a:t>88.9</a:t>
+                      </a:r>
+                    </a:p>
+                  </a:txBody>
+                  <a:tcPr>
+                    <a:solidFill>
+                      <a:srgbClr val="D5F5E3"/>
+                    </a:solidFill>
+                  </a:tcPr>
+                </a:tc>
+                <a:tc>
+                  <a:txBody>
+                    <a:bodyPr/>
+                    <a:lstStyle/>
+                    <a:p>
+                      <a:pPr algn="ctr"/>
+                      <a:r>
+                        <a:rPr sz="1400" b="0">
+                          <a:solidFill>
+                            <a:srgbClr val="2C3E50"/>
+                          </a:solidFill>
+                          <a:latin typeface="맑은 고딕"/>
+                        </a:rPr>
+                        <a:t>90.1</a:t>
+                      </a:r>
+                    </a:p>
+                  </a:txBody>
+                  <a:tcPr>
+                    <a:solidFill>
+                      <a:srgbClr val="D5F5E3"/>
+                    </a:solidFill>
+                  </a:tcPr>
+                </a:tc>
+                <a:tc>
+                  <a:txBody>
+                    <a:bodyPr/>
+                    <a:lstStyle/>
+                    <a:p>
+                      <a:pPr algn="ctr"/>
+                      <a:r>
+                        <a:rPr sz="1400" b="0">
+                          <a:solidFill>
+                            <a:srgbClr val="2C3E50"/>
+                          </a:solidFill>
+                          <a:latin typeface="맑은 고딕"/>
+                        </a:rPr>
+                        <a:t>89.6</a:t>
+                      </a:r>
+                    </a:p>
+                  </a:txBody>
+                  <a:tcPr>
+                    <a:solidFill>
+                      <a:srgbClr val="D5F5E3"/>
+                    </a:solidFill>
+                  </a:tcPr>
+                </a:tc>
+              </a:tr>
+              <a:tr h="441960">
+                <a:tc>
+                  <a:txBody>
+                    <a:bodyPr/>
+                    <a:lstStyle/>
+                    <a:p>
+                      <a:pPr algn="ctr"/>
+                      <a:r>
+                        <a:rPr sz="1400" b="0">
+                          <a:solidFill>
+                            <a:srgbClr val="2C3E50"/>
+                          </a:solidFill>
+                          <a:latin typeface="맑은 고딕"/>
+                        </a:rPr>
+                        <a:t>Double</a:t>
+                      </a:r>
+                    </a:p>
+                  </a:txBody>
+                  <a:tcPr>
+                    <a:solidFill>
+                      <a:srgbClr val="FFFFFF"/>
+                    </a:solidFill>
+                  </a:tcPr>
+                </a:tc>
+                <a:tc>
+                  <a:txBody>
+                    <a:bodyPr/>
+                    <a:lstStyle/>
+                    <a:p>
+                      <a:pPr algn="ctr"/>
+                      <a:r>
+                        <a:rPr sz="1400" b="0">
+                          <a:solidFill>
+                            <a:srgbClr val="2C3E50"/>
+                          </a:solidFill>
+                          <a:latin typeface="맑은 고딕"/>
+                        </a:rPr>
+                        <a:t>1.1%</a:t>
+                      </a:r>
+                    </a:p>
+                  </a:txBody>
+                  <a:tcPr>
+                    <a:solidFill>
+                      <a:srgbClr val="FFFFFF"/>
+                    </a:solidFill>
+                  </a:tcPr>
+                </a:tc>
+                <a:tc>
+                  <a:txBody>
+                    <a:bodyPr/>
+                    <a:lstStyle/>
+                    <a:p>
+                      <a:pPr algn="ctr"/>
+                      <a:r>
+                        <a:rPr sz="1400" b="0">
+                          <a:solidFill>
+                            <a:srgbClr val="2C3E50"/>
+                          </a:solidFill>
+                          <a:latin typeface="맑은 고딕"/>
+                        </a:rPr>
+                        <a:t>0</a:t>
+                      </a:r>
+                    </a:p>
+                  </a:txBody>
+                  <a:tcPr>
+                    <a:solidFill>
+                      <a:srgbClr val="FDEDED"/>
+                    </a:solidFill>
+                  </a:tcPr>
+                </a:tc>
+                <a:tc>
+                  <a:txBody>
+                    <a:bodyPr/>
+                    <a:lstStyle/>
+                    <a:p>
+                      <a:pPr algn="ctr"/>
+                      <a:r>
+                        <a:rPr sz="1400" b="0">
+                          <a:solidFill>
+                            <a:srgbClr val="2C3E50"/>
+                          </a:solidFill>
+                          <a:latin typeface="맑은 고딕"/>
+                        </a:rPr>
+                        <a:t>28.5</a:t>
+                      </a:r>
+                    </a:p>
+                  </a:txBody>
+                  <a:tcPr>
+                    <a:solidFill>
+                      <a:srgbClr val="FFFFFF"/>
+                    </a:solidFill>
+                  </a:tcPr>
+                </a:tc>
+                <a:tc>
+                  <a:txBody>
+                    <a:bodyPr/>
+                    <a:lstStyle/>
+                    <a:p>
+                      <a:pPr algn="ctr"/>
+                      <a:r>
+                        <a:rPr sz="1400" b="0">
+                          <a:solidFill>
+                            <a:srgbClr val="2C3E50"/>
+                          </a:solidFill>
+                          <a:latin typeface="맑은 고딕"/>
+                        </a:rPr>
+                        <a:t>0</a:t>
+                      </a:r>
+                    </a:p>
+                  </a:txBody>
+                  <a:tcPr>
+                    <a:solidFill>
+                      <a:srgbClr val="FDEDED"/>
+                    </a:solidFill>
+                  </a:tcPr>
+                </a:tc>
+                <a:tc>
+                  <a:txBody>
+                    <a:bodyPr/>
+                    <a:lstStyle/>
+                    <a:p>
+                      <a:pPr algn="ctr"/>
+                      <a:r>
+                        <a:rPr sz="1400" b="0">
+                          <a:solidFill>
+                            <a:srgbClr val="2C3E50"/>
+                          </a:solidFill>
+                          <a:latin typeface="맑은 고딕"/>
+                        </a:rPr>
+                        <a:t>37.4</a:t>
+                      </a:r>
+                    </a:p>
+                  </a:txBody>
+                  <a:tcPr>
+                    <a:solidFill>
+                      <a:srgbClr val="FDF2E9"/>
+                    </a:solidFill>
+                  </a:tcPr>
+                </a:tc>
+                <a:tc>
+                  <a:txBody>
+                    <a:bodyPr/>
+                    <a:lstStyle/>
+                    <a:p>
+                      <a:pPr algn="ctr"/>
+                      <a:r>
+                        <a:rPr sz="1400" b="0">
+                          <a:solidFill>
+                            <a:srgbClr val="2C3E50"/>
+                          </a:solidFill>
+                          <a:latin typeface="맑은 고딕"/>
+                        </a:rPr>
+                        <a:t>36.5</a:t>
+                      </a:r>
+                    </a:p>
+                  </a:txBody>
+                  <a:tcPr>
+                    <a:solidFill>
+                      <a:srgbClr val="FDF2E9"/>
+                    </a:solidFill>
+                  </a:tcPr>
+                </a:tc>
+                <a:tc>
+                  <a:txBody>
+                    <a:bodyPr/>
+                    <a:lstStyle/>
+                    <a:p>
+                      <a:pPr algn="ctr"/>
+                      <a:r>
+                        <a:rPr sz="1400" b="0">
+                          <a:solidFill>
+                            <a:srgbClr val="2C3E50"/>
+                          </a:solidFill>
+                          <a:latin typeface="맑은 고딕"/>
+                        </a:rPr>
+                        <a:t>27.5</a:t>
+                      </a:r>
+                    </a:p>
+                  </a:txBody>
+                  <a:tcPr>
+                    <a:solidFill>
+                      <a:srgbClr val="FDF2E9"/>
+                    </a:solidFill>
+                  </a:tcPr>
+                </a:tc>
+              </a:tr>
+              <a:tr h="441960">
+                <a:tc>
+                  <a:txBody>
+                    <a:bodyPr/>
+                    <a:lstStyle/>
+                    <a:p>
+                      <a:pPr algn="ctr"/>
+                      <a:r>
+                        <a:rPr sz="1400" b="0">
+                          <a:solidFill>
+                            <a:srgbClr val="2C3E50"/>
+                          </a:solidFill>
+                          <a:latin typeface="맑은 고딕"/>
+                        </a:rPr>
+                        <a:t>Triple</a:t>
+                      </a:r>
+                    </a:p>
+                  </a:txBody>
+                  <a:tcPr>
+                    <a:solidFill>
+                      <a:srgbClr val="FFFFFF"/>
+                    </a:solidFill>
+                  </a:tcPr>
+                </a:tc>
+                <a:tc>
+                  <a:txBody>
+                    <a:bodyPr/>
+                    <a:lstStyle/>
+                    <a:p>
+                      <a:pPr algn="ctr"/>
+                      <a:r>
+                        <a:rPr sz="1400" b="0">
+                          <a:solidFill>
+                            <a:srgbClr val="2C3E50"/>
+                          </a:solidFill>
+                          <a:latin typeface="맑은 고딕"/>
+                        </a:rPr>
+                        <a:t>0.09%</a:t>
+                      </a:r>
+                    </a:p>
+                  </a:txBody>
+                  <a:tcPr>
+                    <a:solidFill>
+                      <a:srgbClr val="FFFFFF"/>
+                    </a:solidFill>
+                  </a:tcPr>
+                </a:tc>
+                <a:tc>
+                  <a:txBody>
+                    <a:bodyPr/>
+                    <a:lstStyle/>
+                    <a:p>
+                      <a:pPr algn="ctr"/>
+                      <a:r>
+                        <a:rPr sz="1400" b="0">
+                          <a:solidFill>
+                            <a:srgbClr val="2C3E50"/>
+                          </a:solidFill>
+                          <a:latin typeface="맑은 고딕"/>
+                        </a:rPr>
+                        <a:t>0</a:t>
+                      </a:r>
+                    </a:p>
+                  </a:txBody>
+                  <a:tcPr>
+                    <a:solidFill>
+                      <a:srgbClr val="FDEDED"/>
+                    </a:solidFill>
+                  </a:tcPr>
+                </a:tc>
+                <a:tc>
+                  <a:txBody>
+                    <a:bodyPr/>
+                    <a:lstStyle/>
+                    <a:p>
+                      <a:pPr algn="ctr"/>
+                      <a:r>
+                        <a:rPr sz="1400" b="0">
+                          <a:solidFill>
+                            <a:srgbClr val="2C3E50"/>
+                          </a:solidFill>
+                          <a:latin typeface="맑은 고딕"/>
+                        </a:rPr>
+                        <a:t>0</a:t>
+                      </a:r>
+                    </a:p>
+                  </a:txBody>
+                  <a:tcPr>
+                    <a:solidFill>
+                      <a:srgbClr val="FDEDED"/>
+                    </a:solidFill>
+                  </a:tcPr>
+                </a:tc>
+                <a:tc>
+                  <a:txBody>
+                    <a:bodyPr/>
+                    <a:lstStyle/>
+                    <a:p>
+                      <a:pPr algn="ctr"/>
+                      <a:r>
+                        <a:rPr sz="1400" b="0">
+                          <a:solidFill>
+                            <a:srgbClr val="2C3E50"/>
+                          </a:solidFill>
+                          <a:latin typeface="맑은 고딕"/>
+                        </a:rPr>
+                        <a:t>0</a:t>
+                      </a:r>
+                    </a:p>
+                  </a:txBody>
+                  <a:tcPr>
+                    <a:solidFill>
+                      <a:srgbClr val="FDEDED"/>
+                    </a:solidFill>
+                  </a:tcPr>
+                </a:tc>
+                <a:tc>
+                  <a:txBody>
+                    <a:bodyPr/>
+                    <a:lstStyle/>
+                    <a:p>
+                      <a:pPr algn="ctr"/>
+                      <a:r>
+                        <a:rPr sz="1400" b="0">
+                          <a:solidFill>
+                            <a:srgbClr val="2C3E50"/>
+                          </a:solidFill>
+                          <a:latin typeface="맑은 고딕"/>
+                        </a:rPr>
+                        <a:t>0</a:t>
+                      </a:r>
+                    </a:p>
+                  </a:txBody>
+                  <a:tcPr>
+                    <a:solidFill>
+                      <a:srgbClr val="FDEDED"/>
+                    </a:solidFill>
+                  </a:tcPr>
+                </a:tc>
+                <a:tc>
+                  <a:txBody>
+                    <a:bodyPr/>
+                    <a:lstStyle/>
+                    <a:p>
+                      <a:pPr algn="ctr"/>
+                      <a:r>
+                        <a:rPr sz="1400" b="0">
+                          <a:solidFill>
+                            <a:srgbClr val="2C3E50"/>
+                          </a:solidFill>
+                          <a:latin typeface="맑은 고딕"/>
+                        </a:rPr>
+                        <a:t>0</a:t>
+                      </a:r>
+                    </a:p>
+                  </a:txBody>
+                  <a:tcPr>
+                    <a:solidFill>
+                      <a:srgbClr val="FDEDED"/>
+                    </a:solidFill>
+                  </a:tcPr>
+                </a:tc>
+                <a:tc>
+                  <a:txBody>
+                    <a:bodyPr/>
+                    <a:lstStyle/>
+                    <a:p>
+                      <a:pPr algn="ctr"/>
+                      <a:r>
+                        <a:rPr sz="1400" b="0">
+                          <a:solidFill>
+                            <a:srgbClr val="2C3E50"/>
+                          </a:solidFill>
+                          <a:latin typeface="맑은 고딕"/>
+                        </a:rPr>
+                        <a:t>0</a:t>
+                      </a:r>
+                    </a:p>
+                  </a:txBody>
+                  <a:tcPr>
+                    <a:solidFill>
+                      <a:srgbClr val="FDEDED"/>
+                    </a:solidFill>
+                  </a:tcPr>
+                </a:tc>
+              </a:tr>
+              <a:tr h="441960">
+                <a:tc>
+                  <a:txBody>
+                    <a:bodyPr/>
+                    <a:lstStyle/>
+                    <a:p>
+                      <a:pPr algn="ctr"/>
+                      <a:r>
+                        <a:rPr sz="1400" b="0">
+                          <a:solidFill>
+                            <a:srgbClr val="2C3E50"/>
+                          </a:solidFill>
+                          <a:latin typeface="맑은 고딕"/>
+                        </a:rPr>
+                        <a:t>HomeRun</a:t>
+                      </a:r>
+                    </a:p>
+                  </a:txBody>
+                  <a:tcPr>
+                    <a:solidFill>
+                      <a:srgbClr val="FFFFFF"/>
+                    </a:solidFill>
+                  </a:tcPr>
+                </a:tc>
+                <a:tc>
+                  <a:txBody>
+                    <a:bodyPr/>
+                    <a:lstStyle/>
+                    <a:p>
+                      <a:pPr algn="ctr"/>
+                      <a:r>
+                        <a:rPr sz="1400" b="0">
+                          <a:solidFill>
+                            <a:srgbClr val="2C3E50"/>
+                          </a:solidFill>
+                          <a:latin typeface="맑은 고딕"/>
+                        </a:rPr>
+                        <a:t>0.8%</a:t>
+                      </a:r>
+                    </a:p>
+                  </a:txBody>
+                  <a:tcPr>
+                    <a:solidFill>
+                      <a:srgbClr val="FFFFFF"/>
+                    </a:solidFill>
+                  </a:tcPr>
+                </a:tc>
+                <a:tc>
+                  <a:txBody>
+                    <a:bodyPr/>
+                    <a:lstStyle/>
+                    <a:p>
+                      <a:pPr algn="ctr"/>
+                      <a:r>
+                        <a:rPr sz="1400" b="0">
+                          <a:solidFill>
+                            <a:srgbClr val="2C3E50"/>
+                          </a:solidFill>
+                          <a:latin typeface="맑은 고딕"/>
+                        </a:rPr>
+                        <a:t>0</a:t>
+                      </a:r>
+                    </a:p>
+                  </a:txBody>
+                  <a:tcPr>
+                    <a:solidFill>
+                      <a:srgbClr val="FDEDED"/>
+                    </a:solidFill>
+                  </a:tcPr>
+                </a:tc>
+                <a:tc>
+                  <a:txBody>
+                    <a:bodyPr/>
+                    <a:lstStyle/>
+                    <a:p>
+                      <a:pPr algn="ctr"/>
+                      <a:r>
+                        <a:rPr sz="1400" b="0">
+                          <a:solidFill>
+                            <a:srgbClr val="2C3E50"/>
+                          </a:solidFill>
+                          <a:latin typeface="맑은 고딕"/>
+                        </a:rPr>
+                        <a:t>20.5</a:t>
+                      </a:r>
+                    </a:p>
+                  </a:txBody>
+                  <a:tcPr>
+                    <a:solidFill>
+                      <a:srgbClr val="FFFFFF"/>
+                    </a:solidFill>
+                  </a:tcPr>
+                </a:tc>
+                <a:tc>
+                  <a:txBody>
+                    <a:bodyPr/>
+                    <a:lstStyle/>
+                    <a:p>
+                      <a:pPr algn="ctr"/>
+                      <a:r>
+                        <a:rPr sz="1400" b="0">
+                          <a:solidFill>
+                            <a:srgbClr val="2C3E50"/>
+                          </a:solidFill>
+                          <a:latin typeface="맑은 고딕"/>
+                        </a:rPr>
+                        <a:t>0</a:t>
+                      </a:r>
+                    </a:p>
+                  </a:txBody>
+                  <a:tcPr>
+                    <a:solidFill>
+                      <a:srgbClr val="FDEDED"/>
+                    </a:solidFill>
+                  </a:tcPr>
+                </a:tc>
+                <a:tc>
+                  <a:txBody>
+                    <a:bodyPr/>
+                    <a:lstStyle/>
+                    <a:p>
+                      <a:pPr algn="ctr"/>
+                      <a:r>
+                        <a:rPr sz="1400" b="0">
+                          <a:solidFill>
+                            <a:srgbClr val="2C3E50"/>
+                          </a:solidFill>
+                          <a:latin typeface="맑은 고딕"/>
+                        </a:rPr>
+                        <a:t>18.1</a:t>
+                      </a:r>
+                    </a:p>
+                  </a:txBody>
+                  <a:tcPr>
+                    <a:solidFill>
+                      <a:srgbClr val="FDF2E9"/>
+                    </a:solidFill>
+                  </a:tcPr>
+                </a:tc>
+                <a:tc>
+                  <a:txBody>
+                    <a:bodyPr/>
+                    <a:lstStyle/>
+                    <a:p>
+                      <a:pPr algn="ctr"/>
+                      <a:r>
+                        <a:rPr sz="1400" b="0">
+                          <a:solidFill>
+                            <a:srgbClr val="2C3E50"/>
+                          </a:solidFill>
+                          <a:latin typeface="맑은 고딕"/>
+                        </a:rPr>
+                        <a:t>10.4</a:t>
+                      </a:r>
+                    </a:p>
+                  </a:txBody>
+                  <a:tcPr>
+                    <a:solidFill>
+                      <a:srgbClr val="FDF2E9"/>
+                    </a:solidFill>
+                  </a:tcPr>
+                </a:tc>
+                <a:tc>
+                  <a:txBody>
+                    <a:bodyPr/>
+                    <a:lstStyle/>
+                    <a:p>
+                      <a:pPr algn="ctr"/>
+                      <a:r>
+                        <a:rPr sz="1400" b="0">
+                          <a:solidFill>
+                            <a:srgbClr val="2C3E50"/>
+                          </a:solidFill>
+                          <a:latin typeface="맑은 고딕"/>
+                        </a:rPr>
+                        <a:t>15.6</a:t>
+                      </a:r>
+                    </a:p>
+                  </a:txBody>
+                  <a:tcPr>
+                    <a:solidFill>
+                      <a:srgbClr val="FDF2E9"/>
+                    </a:solidFill>
+                  </a:tcPr>
+                </a:tc>
+              </a:tr>
+              <a:tr h="441960">
+                <a:tc>
+                  <a:txBody>
+                    <a:bodyPr/>
+                    <a:lstStyle/>
+                    <a:p>
+                      <a:pPr algn="ctr"/>
+                      <a:r>
+                        <a:rPr sz="1400" b="0">
+                          <a:solidFill>
+                            <a:srgbClr val="2C3E50"/>
+                          </a:solidFill>
+                          <a:latin typeface="맑은 고딕"/>
+                        </a:rPr>
+                        <a:t>FieldOut</a:t>
+                      </a:r>
+                    </a:p>
+                  </a:txBody>
+                  <a:tcPr>
+                    <a:solidFill>
+                      <a:srgbClr val="FFFFFF"/>
+                    </a:solidFill>
+                  </a:tcPr>
+                </a:tc>
+                <a:tc>
+                  <a:txBody>
+                    <a:bodyPr/>
+                    <a:lstStyle/>
+                    <a:p>
+                      <a:pPr algn="ctr"/>
+                      <a:r>
+                        <a:rPr sz="1400" b="0">
+                          <a:solidFill>
+                            <a:srgbClr val="2C3E50"/>
+                          </a:solidFill>
+                          <a:latin typeface="맑은 고딕"/>
+                        </a:rPr>
+                        <a:t>11.8%</a:t>
+                      </a:r>
+                    </a:p>
+                  </a:txBody>
+                  <a:tcPr>
+                    <a:solidFill>
+                      <a:srgbClr val="FFFFFF"/>
+                    </a:solidFill>
+                  </a:tcPr>
+                </a:tc>
+                <a:tc>
+                  <a:txBody>
+                    <a:bodyPr/>
+                    <a:lstStyle/>
+                    <a:p>
+                      <a:pPr algn="ctr"/>
+                      <a:r>
+                        <a:rPr sz="1400" b="0">
+                          <a:solidFill>
+                            <a:srgbClr val="2C3E50"/>
+                          </a:solidFill>
+                          <a:latin typeface="맑은 고딕"/>
+                        </a:rPr>
+                        <a:t>100</a:t>
+                      </a:r>
+                    </a:p>
+                  </a:txBody>
+                  <a:tcPr>
+                    <a:solidFill>
+                      <a:srgbClr val="FFFFFF"/>
+                    </a:solidFill>
+                  </a:tcPr>
+                </a:tc>
+                <a:tc>
+                  <a:txBody>
+                    <a:bodyPr/>
+                    <a:lstStyle/>
+                    <a:p>
+                      <a:pPr algn="ctr"/>
+                      <a:r>
+                        <a:rPr sz="1400" b="0">
+                          <a:solidFill>
+                            <a:srgbClr val="2C3E50"/>
+                          </a:solidFill>
+                          <a:latin typeface="맑은 고딕"/>
+                        </a:rPr>
+                        <a:t>62.2</a:t>
+                      </a:r>
+                    </a:p>
+                  </a:txBody>
+                  <a:tcPr>
+                    <a:solidFill>
+                      <a:srgbClr val="FFFFFF"/>
+                    </a:solidFill>
+                  </a:tcPr>
+                </a:tc>
+                <a:tc>
+                  <a:txBody>
+                    <a:bodyPr/>
+                    <a:lstStyle/>
+                    <a:p>
+                      <a:pPr algn="ctr"/>
+                      <a:r>
+                        <a:rPr sz="1400" b="0">
+                          <a:solidFill>
+                            <a:srgbClr val="2C3E50"/>
+                          </a:solidFill>
+                          <a:latin typeface="맑은 고딕"/>
+                        </a:rPr>
+                        <a:t>100</a:t>
+                      </a:r>
+                    </a:p>
+                  </a:txBody>
+                  <a:tcPr>
+                    <a:solidFill>
+                      <a:srgbClr val="FFFFFF"/>
+                    </a:solidFill>
+                  </a:tcPr>
+                </a:tc>
+                <a:tc>
+                  <a:txBody>
+                    <a:bodyPr/>
+                    <a:lstStyle/>
+                    <a:p>
+                      <a:pPr algn="ctr"/>
+                      <a:r>
+                        <a:rPr sz="1400" b="0">
+                          <a:solidFill>
+                            <a:srgbClr val="2C3E50"/>
+                          </a:solidFill>
+                          <a:latin typeface="맑은 고딕"/>
+                        </a:rPr>
+                        <a:t>100</a:t>
+                      </a:r>
+                    </a:p>
+                  </a:txBody>
+                  <a:tcPr>
+                    <a:solidFill>
+                      <a:srgbClr val="D5F5E3"/>
+                    </a:solidFill>
+                  </a:tcPr>
+                </a:tc>
+                <a:tc>
+                  <a:txBody>
+                    <a:bodyPr/>
+                    <a:lstStyle/>
+                    <a:p>
+                      <a:pPr algn="ctr"/>
+                      <a:r>
+                        <a:rPr sz="1400" b="0">
+                          <a:solidFill>
+                            <a:srgbClr val="2C3E50"/>
+                          </a:solidFill>
+                          <a:latin typeface="맑은 고딕"/>
+                        </a:rPr>
+                        <a:t>100</a:t>
+                      </a:r>
+                    </a:p>
+                  </a:txBody>
+                  <a:tcPr>
+                    <a:solidFill>
+                      <a:srgbClr val="D5F5E3"/>
+                    </a:solidFill>
+                  </a:tcPr>
+                </a:tc>
+                <a:tc>
+                  <a:txBody>
+                    <a:bodyPr/>
+                    <a:lstStyle/>
+                    <a:p>
+                      <a:pPr algn="ctr"/>
+                      <a:r>
+                        <a:rPr sz="1400" b="0">
+                          <a:solidFill>
+                            <a:srgbClr val="2C3E50"/>
+                          </a:solidFill>
+                          <a:latin typeface="맑은 고딕"/>
+                        </a:rPr>
+                        <a:t>100</a:t>
+                      </a:r>
+                    </a:p>
+                  </a:txBody>
+                  <a:tcPr>
+                    <a:solidFill>
+                      <a:srgbClr val="D5F5E3"/>
+                    </a:solidFill>
+                  </a:tcPr>
+                </a:tc>
+              </a:tr>
+              <a:tr h="441960">
+                <a:tc>
+                  <a:txBody>
+                    <a:bodyPr/>
+                    <a:lstStyle/>
+                    <a:p>
+                      <a:pPr algn="ctr"/>
+                      <a:r>
+                        <a:rPr sz="1400" b="0">
+                          <a:solidFill>
+                            <a:srgbClr val="2C3E50"/>
+                          </a:solidFill>
+                          <a:latin typeface="맑은 고딕"/>
+                        </a:rPr>
+                        <a:t>Strikeout</a:t>
+                      </a:r>
+                    </a:p>
+                  </a:txBody>
+                  <a:tcPr>
+                    <a:solidFill>
+                      <a:srgbClr val="FFFFFF"/>
+                    </a:solidFill>
+                  </a:tcPr>
+                </a:tc>
+                <a:tc>
+                  <a:txBody>
+                    <a:bodyPr/>
+                    <a:lstStyle/>
+                    <a:p>
+                      <a:pPr algn="ctr"/>
+                      <a:r>
+                        <a:rPr sz="1400" b="0">
+                          <a:solidFill>
+                            <a:srgbClr val="2C3E50"/>
+                          </a:solidFill>
+                          <a:latin typeface="맑은 고딕"/>
+                        </a:rPr>
+                        <a:t>5.9%</a:t>
+                      </a:r>
+                    </a:p>
+                  </a:txBody>
+                  <a:tcPr>
+                    <a:solidFill>
+                      <a:srgbClr val="FFFFFF"/>
+                    </a:solidFill>
+                  </a:tcPr>
+                </a:tc>
+                <a:tc>
+                  <a:txBody>
+                    <a:bodyPr/>
+                    <a:lstStyle/>
+                    <a:p>
+                      <a:pPr algn="ctr"/>
+                      <a:r>
+                        <a:rPr sz="1400" b="0">
+                          <a:solidFill>
+                            <a:srgbClr val="2C3E50"/>
+                          </a:solidFill>
+                          <a:latin typeface="맑은 고딕"/>
+                        </a:rPr>
+                        <a:t>99.8</a:t>
+                      </a:r>
+                    </a:p>
+                  </a:txBody>
+                  <a:tcPr>
+                    <a:solidFill>
+                      <a:srgbClr val="FFFFFF"/>
+                    </a:solidFill>
+                  </a:tcPr>
+                </a:tc>
+                <a:tc>
+                  <a:txBody>
+                    <a:bodyPr/>
+                    <a:lstStyle/>
+                    <a:p>
+                      <a:pPr algn="ctr"/>
+                      <a:r>
+                        <a:rPr sz="1400" b="0">
+                          <a:solidFill>
+                            <a:srgbClr val="2C3E50"/>
+                          </a:solidFill>
+                          <a:latin typeface="맑은 고딕"/>
+                        </a:rPr>
+                        <a:t>54.3</a:t>
+                      </a:r>
+                    </a:p>
+                  </a:txBody>
+                  <a:tcPr>
+                    <a:solidFill>
+                      <a:srgbClr val="FFFFFF"/>
+                    </a:solidFill>
+                  </a:tcPr>
+                </a:tc>
+                <a:tc>
+                  <a:txBody>
+                    <a:bodyPr/>
+                    <a:lstStyle/>
+                    <a:p>
+                      <a:pPr algn="ctr"/>
+                      <a:r>
+                        <a:rPr sz="1400" b="0">
+                          <a:solidFill>
+                            <a:srgbClr val="2C3E50"/>
+                          </a:solidFill>
+                          <a:latin typeface="맑은 고딕"/>
+                        </a:rPr>
+                        <a:t>100</a:t>
+                      </a:r>
+                    </a:p>
+                  </a:txBody>
+                  <a:tcPr>
+                    <a:solidFill>
+                      <a:srgbClr val="FFFFFF"/>
+                    </a:solidFill>
+                  </a:tcPr>
+                </a:tc>
+                <a:tc>
+                  <a:txBody>
+                    <a:bodyPr/>
+                    <a:lstStyle/>
+                    <a:p>
+                      <a:pPr algn="ctr"/>
+                      <a:r>
+                        <a:rPr sz="1400" b="0">
+                          <a:solidFill>
+                            <a:srgbClr val="2C3E50"/>
+                          </a:solidFill>
+                          <a:latin typeface="맑은 고딕"/>
+                        </a:rPr>
+                        <a:t>100</a:t>
+                      </a:r>
+                    </a:p>
+                  </a:txBody>
+                  <a:tcPr>
+                    <a:solidFill>
+                      <a:srgbClr val="D5F5E3"/>
+                    </a:solidFill>
+                  </a:tcPr>
+                </a:tc>
+                <a:tc>
+                  <a:txBody>
+                    <a:bodyPr/>
+                    <a:lstStyle/>
+                    <a:p>
+                      <a:pPr algn="ctr"/>
+                      <a:r>
+                        <a:rPr sz="1400" b="0">
+                          <a:solidFill>
+                            <a:srgbClr val="2C3E50"/>
+                          </a:solidFill>
+                          <a:latin typeface="맑은 고딕"/>
+                        </a:rPr>
+                        <a:t>99.9</a:t>
+                      </a:r>
+                    </a:p>
+                  </a:txBody>
+                  <a:tcPr>
+                    <a:solidFill>
+                      <a:srgbClr val="D5F5E3"/>
+                    </a:solidFill>
+                  </a:tcPr>
+                </a:tc>
+                <a:tc>
+                  <a:txBody>
+                    <a:bodyPr/>
+                    <a:lstStyle/>
+                    <a:p>
+                      <a:pPr algn="ctr"/>
+                      <a:r>
+                        <a:rPr sz="1400" b="0">
+                          <a:solidFill>
+                            <a:srgbClr val="2C3E50"/>
+                          </a:solidFill>
+                          <a:latin typeface="맑은 고딕"/>
+                        </a:rPr>
+                        <a:t>99.8</a:t>
+                      </a:r>
+                    </a:p>
+                  </a:txBody>
+                  <a:tcPr>
+                    <a:solidFill>
+                      <a:srgbClr val="D5F5E3"/>
+                    </a:solidFill>
+                  </a:tcPr>
+                </a:tc>
+              </a:tr>
+              <a:tr h="441960">
+                <a:tc>
+                  <a:txBody>
+                    <a:bodyPr/>
+                    <a:lstStyle/>
+                    <a:p>
+                      <a:pPr algn="ctr"/>
+                      <a:r>
+                        <a:rPr sz="1400" b="0">
+                          <a:solidFill>
+                            <a:srgbClr val="2C3E50"/>
+                          </a:solidFill>
+                          <a:latin typeface="맑은 고딕"/>
+                        </a:rPr>
+                        <a:t>Walk</a:t>
+                      </a:r>
+                    </a:p>
+                  </a:txBody>
+                  <a:tcPr>
+                    <a:solidFill>
+                      <a:srgbClr val="FFFFFF"/>
+                    </a:solidFill>
+                  </a:tcPr>
+                </a:tc>
+                <a:tc>
+                  <a:txBody>
+                    <a:bodyPr/>
+                    <a:lstStyle/>
+                    <a:p>
+                      <a:pPr algn="ctr"/>
+                      <a:r>
+                        <a:rPr sz="1400" b="0">
+                          <a:solidFill>
+                            <a:srgbClr val="2C3E50"/>
+                          </a:solidFill>
+                          <a:latin typeface="맑은 고딕"/>
+                        </a:rPr>
+                        <a:t>2.0%</a:t>
+                      </a:r>
+                    </a:p>
+                  </a:txBody>
+                  <a:tcPr>
+                    <a:solidFill>
+                      <a:srgbClr val="FFFFFF"/>
+                    </a:solidFill>
+                  </a:tcPr>
+                </a:tc>
+                <a:tc>
+                  <a:txBody>
+                    <a:bodyPr/>
+                    <a:lstStyle/>
+                    <a:p>
+                      <a:pPr algn="ctr"/>
+                      <a:r>
+                        <a:rPr sz="1400" b="0">
+                          <a:solidFill>
+                            <a:srgbClr val="2C3E50"/>
+                          </a:solidFill>
+                          <a:latin typeface="맑은 고딕"/>
+                        </a:rPr>
+                        <a:t>0</a:t>
+                      </a:r>
+                    </a:p>
+                  </a:txBody>
+                  <a:tcPr>
+                    <a:solidFill>
+                      <a:srgbClr val="FDEDED"/>
+                    </a:solidFill>
+                  </a:tcPr>
+                </a:tc>
+                <a:tc>
+                  <a:txBody>
+                    <a:bodyPr/>
+                    <a:lstStyle/>
+                    <a:p>
+                      <a:pPr algn="ctr"/>
+                      <a:r>
+                        <a:rPr sz="1400" b="0">
+                          <a:solidFill>
+                            <a:srgbClr val="2C3E50"/>
+                          </a:solidFill>
+                          <a:latin typeface="맑은 고딕"/>
+                        </a:rPr>
+                        <a:t>38.3</a:t>
+                      </a:r>
+                    </a:p>
+                  </a:txBody>
+                  <a:tcPr>
+                    <a:solidFill>
+                      <a:srgbClr val="FFFFFF"/>
+                    </a:solidFill>
+                  </a:tcPr>
+                </a:tc>
+                <a:tc>
+                  <a:txBody>
+                    <a:bodyPr/>
+                    <a:lstStyle/>
+                    <a:p>
+                      <a:pPr algn="ctr"/>
+                      <a:r>
+                        <a:rPr sz="1400" b="0">
+                          <a:solidFill>
+                            <a:srgbClr val="2C3E50"/>
+                          </a:solidFill>
+                          <a:latin typeface="맑은 고딕"/>
+                        </a:rPr>
+                        <a:t>0</a:t>
+                      </a:r>
+                    </a:p>
+                  </a:txBody>
+                  <a:tcPr>
+                    <a:solidFill>
+                      <a:srgbClr val="FDEDED"/>
+                    </a:solidFill>
+                  </a:tcPr>
+                </a:tc>
+                <a:tc>
+                  <a:txBody>
+                    <a:bodyPr/>
+                    <a:lstStyle/>
+                    <a:p>
+                      <a:pPr algn="ctr"/>
+                      <a:r>
+                        <a:rPr sz="1400" b="0">
+                          <a:solidFill>
+                            <a:srgbClr val="2C3E50"/>
+                          </a:solidFill>
+                          <a:latin typeface="맑은 고딕"/>
+                        </a:rPr>
+                        <a:t>98.2</a:t>
+                      </a:r>
+                    </a:p>
+                  </a:txBody>
+                  <a:tcPr>
+                    <a:solidFill>
+                      <a:srgbClr val="D5F5E3"/>
+                    </a:solidFill>
+                  </a:tcPr>
+                </a:tc>
+                <a:tc>
+                  <a:txBody>
+                    <a:bodyPr/>
+                    <a:lstStyle/>
+                    <a:p>
+                      <a:pPr algn="ctr"/>
+                      <a:r>
+                        <a:rPr sz="1400" b="0">
+                          <a:solidFill>
+                            <a:srgbClr val="2C3E50"/>
+                          </a:solidFill>
+                          <a:latin typeface="맑은 고딕"/>
+                        </a:rPr>
+                        <a:t>98.0</a:t>
+                      </a:r>
+                    </a:p>
+                  </a:txBody>
+                  <a:tcPr>
+                    <a:solidFill>
+                      <a:srgbClr val="D5F5E3"/>
+                    </a:solidFill>
+                  </a:tcPr>
+                </a:tc>
+                <a:tc>
+                  <a:txBody>
+                    <a:bodyPr/>
+                    <a:lstStyle/>
+                    <a:p>
+                      <a:pPr algn="ctr"/>
+                      <a:r>
+                        <a:rPr sz="1400" b="0">
+                          <a:solidFill>
+                            <a:srgbClr val="2C3E50"/>
+                          </a:solidFill>
+                          <a:latin typeface="맑은 고딕"/>
+                        </a:rPr>
+                        <a:t>99.0</a:t>
+                      </a:r>
+                    </a:p>
+                  </a:txBody>
+                  <a:tcPr>
+                    <a:solidFill>
+                      <a:srgbClr val="D5F5E3"/>
+                    </a:solidFill>
+                  </a:tcPr>
+                </a:tc>
+              </a:tr>
+              <a:tr h="441960">
+                <a:tc>
+                  <a:txBody>
+                    <a:bodyPr/>
+                    <a:lstStyle/>
+                    <a:p>
+                      <a:pPr algn="ctr"/>
+                      <a:r>
+                        <a:rPr sz="1400" b="0">
+                          <a:solidFill>
+                            <a:srgbClr val="2C3E50"/>
+                          </a:solidFill>
+                          <a:latin typeface="맑은 고딕"/>
+                        </a:rPr>
+                        <a:t>HBP</a:t>
+                      </a:r>
+                    </a:p>
+                  </a:txBody>
+                  <a:tcPr>
+                    <a:solidFill>
+                      <a:srgbClr val="FFFFFF"/>
+                    </a:solidFill>
+                  </a:tcPr>
+                </a:tc>
+                <a:tc>
+                  <a:txBody>
+                    <a:bodyPr/>
+                    <a:lstStyle/>
+                    <a:p>
+                      <a:pPr algn="ctr"/>
+                      <a:r>
+                        <a:rPr sz="1400" b="0">
+                          <a:solidFill>
+                            <a:srgbClr val="2C3E50"/>
+                          </a:solidFill>
+                          <a:latin typeface="맑은 고딕"/>
+                        </a:rPr>
+                        <a:t>0.3%</a:t>
+                      </a:r>
+                    </a:p>
+                  </a:txBody>
+                  <a:tcPr>
+                    <a:solidFill>
+                      <a:srgbClr val="FFFFFF"/>
+                    </a:solidFill>
+                  </a:tcPr>
+                </a:tc>
+                <a:tc>
+                  <a:txBody>
+                    <a:bodyPr/>
+                    <a:lstStyle/>
+                    <a:p>
+                      <a:pPr algn="ctr"/>
+                      <a:r>
+                        <a:rPr sz="1400" b="0">
+                          <a:solidFill>
+                            <a:srgbClr val="2C3E50"/>
+                          </a:solidFill>
+                          <a:latin typeface="맑은 고딕"/>
+                        </a:rPr>
+                        <a:t>0</a:t>
+                      </a:r>
+                    </a:p>
+                  </a:txBody>
+                  <a:tcPr>
+                    <a:solidFill>
+                      <a:srgbClr val="FDEDED"/>
+                    </a:solidFill>
+                  </a:tcPr>
+                </a:tc>
+                <a:tc>
+                  <a:txBody>
+                    <a:bodyPr/>
+                    <a:lstStyle/>
+                    <a:p>
+                      <a:pPr algn="ctr"/>
+                      <a:r>
+                        <a:rPr sz="1400" b="0">
+                          <a:solidFill>
+                            <a:srgbClr val="2C3E50"/>
+                          </a:solidFill>
+                          <a:latin typeface="맑은 고딕"/>
+                        </a:rPr>
+                        <a:t>5.7</a:t>
+                      </a:r>
+                    </a:p>
+                  </a:txBody>
+                  <a:tcPr>
+                    <a:solidFill>
+                      <a:srgbClr val="FFFFFF"/>
+                    </a:solidFill>
+                  </a:tcPr>
+                </a:tc>
+                <a:tc>
+                  <a:txBody>
+                    <a:bodyPr/>
+                    <a:lstStyle/>
+                    <a:p>
+                      <a:pPr algn="ctr"/>
+                      <a:r>
+                        <a:rPr sz="1400" b="0">
+                          <a:solidFill>
+                            <a:srgbClr val="2C3E50"/>
+                          </a:solidFill>
+                          <a:latin typeface="맑은 고딕"/>
+                        </a:rPr>
+                        <a:t>0</a:t>
+                      </a:r>
+                    </a:p>
+                  </a:txBody>
+                  <a:tcPr>
+                    <a:solidFill>
+                      <a:srgbClr val="FDEDED"/>
+                    </a:solidFill>
+                  </a:tcPr>
+                </a:tc>
+                <a:tc>
+                  <a:txBody>
+                    <a:bodyPr/>
+                    <a:lstStyle/>
+                    <a:p>
+                      <a:pPr algn="ctr"/>
+                      <a:r>
+                        <a:rPr sz="1400" b="0">
+                          <a:solidFill>
+                            <a:srgbClr val="2C3E50"/>
+                          </a:solidFill>
+                          <a:latin typeface="맑은 고딕"/>
+                        </a:rPr>
+                        <a:t>95.3</a:t>
+                      </a:r>
+                    </a:p>
+                  </a:txBody>
+                  <a:tcPr>
+                    <a:solidFill>
+                      <a:srgbClr val="D5F5E3"/>
+                    </a:solidFill>
+                  </a:tcPr>
+                </a:tc>
+                <a:tc>
+                  <a:txBody>
+                    <a:bodyPr/>
+                    <a:lstStyle/>
+                    <a:p>
+                      <a:pPr algn="ctr"/>
+                      <a:r>
+                        <a:rPr sz="1400" b="0">
+                          <a:solidFill>
+                            <a:srgbClr val="2C3E50"/>
+                          </a:solidFill>
+                          <a:latin typeface="맑은 고딕"/>
+                        </a:rPr>
+                        <a:t>92.2</a:t>
+                      </a:r>
+                    </a:p>
+                  </a:txBody>
+                  <a:tcPr>
+                    <a:solidFill>
+                      <a:srgbClr val="D5F5E3"/>
+                    </a:solidFill>
+                  </a:tcPr>
+                </a:tc>
+                <a:tc>
+                  <a:txBody>
+                    <a:bodyPr/>
+                    <a:lstStyle/>
+                    <a:p>
+                      <a:pPr algn="ctr"/>
+                      <a:r>
+                        <a:rPr sz="1400" b="0">
+                          <a:solidFill>
+                            <a:srgbClr val="2C3E50"/>
+                          </a:solidFill>
+                          <a:latin typeface="맑은 고딕"/>
+                        </a:rPr>
+                        <a:t>92.2</a:t>
+                      </a:r>
+                    </a:p>
+                  </a:txBody>
+                  <a:tcPr>
+                    <a:solidFill>
+                      <a:srgbClr val="D5F5E3"/>
+                    </a:solidFill>
+                  </a:tcPr>
+                </a:tc>
+              </a:tr>
+              <a:tr h="441960">
+                <a:tc>
+                  <a:txBody>
+                    <a:bodyPr/>
+                    <a:lstStyle/>
+                    <a:p>
+                      <a:pPr algn="ctr"/>
+                      <a:r>
+                        <a:rPr sz="1400" b="1">
+                          <a:solidFill>
+                            <a:srgbClr val="FFFFFF"/>
+                          </a:solidFill>
+                          <a:latin typeface="맑은 고딕"/>
+                        </a:rPr>
+                        <a:t>Overall</a:t>
+                      </a:r>
+                    </a:p>
+                  </a:txBody>
+                  <a:tcPr>
+                    <a:solidFill>
+                      <a:srgbClr val="2C3E50"/>
+                    </a:solidFill>
+                  </a:tcPr>
+                </a:tc>
+                <a:tc>
+                  <a:txBody>
+                    <a:bodyPr/>
+                    <a:lstStyle/>
+                    <a:p>
+                      <a:pPr algn="ctr"/>
+                      <a:r>
+                        <a:rPr sz="1400" b="1">
+                          <a:solidFill>
+                            <a:srgbClr val="FFFFFF"/>
+                          </a:solidFill>
+                          <a:latin typeface="맑은 고딕"/>
+                        </a:rPr>
+                        <a:t>—</a:t>
+                      </a:r>
+                    </a:p>
+                  </a:txBody>
+                  <a:tcPr>
+                    <a:solidFill>
+                      <a:srgbClr val="2C3E50"/>
+                    </a:solidFill>
+                  </a:tcPr>
+                </a:tc>
+                <a:tc>
+                  <a:txBody>
+                    <a:bodyPr/>
+                    <a:lstStyle/>
+                    <a:p>
+                      <a:pPr algn="ctr"/>
+                      <a:r>
+                        <a:rPr sz="1400" b="1">
+                          <a:solidFill>
+                            <a:srgbClr val="FFFFFF"/>
+                          </a:solidFill>
+                          <a:latin typeface="맑은 고딕"/>
+                        </a:rPr>
+                        <a:t>92.1</a:t>
+                      </a:r>
+                    </a:p>
+                  </a:txBody>
+                  <a:tcPr>
+                    <a:solidFill>
+                      <a:srgbClr val="2C3E50"/>
+                    </a:solidFill>
+                  </a:tcPr>
+                </a:tc>
+                <a:tc>
+                  <a:txBody>
+                    <a:bodyPr/>
+                    <a:lstStyle/>
+                    <a:p>
+                      <a:pPr algn="ctr"/>
+                      <a:r>
+                        <a:rPr sz="1400" b="1">
+                          <a:solidFill>
+                            <a:srgbClr val="FFFFFF"/>
+                          </a:solidFill>
+                          <a:latin typeface="맑은 고딕"/>
+                        </a:rPr>
+                        <a:t>66.0</a:t>
+                      </a:r>
+                    </a:p>
+                  </a:txBody>
+                  <a:tcPr>
+                    <a:solidFill>
+                      <a:srgbClr val="2C3E50"/>
+                    </a:solidFill>
+                  </a:tcPr>
+                </a:tc>
+                <a:tc>
+                  <a:txBody>
+                    <a:bodyPr/>
+                    <a:lstStyle/>
+                    <a:p>
+                      <a:pPr algn="ctr"/>
+                      <a:r>
+                        <a:rPr sz="1400" b="1">
+                          <a:solidFill>
+                            <a:srgbClr val="FFFFFF"/>
+                          </a:solidFill>
+                          <a:latin typeface="맑은 고딕"/>
+                        </a:rPr>
+                        <a:t>92.1</a:t>
+                      </a:r>
+                    </a:p>
+                  </a:txBody>
+                  <a:tcPr>
+                    <a:solidFill>
+                      <a:srgbClr val="2C3E50"/>
+                    </a:solidFill>
+                  </a:tcPr>
+                </a:tc>
+                <a:tc>
+                  <a:txBody>
+                    <a:bodyPr/>
+                    <a:lstStyle/>
+                    <a:p>
+                      <a:pPr algn="ctr"/>
+                      <a:r>
+                        <a:rPr sz="1400" b="1">
+                          <a:solidFill>
+                            <a:srgbClr val="FFFFFF"/>
+                          </a:solidFill>
+                          <a:latin typeface="맑은 고딕"/>
+                        </a:rPr>
+                        <a:t>98.0</a:t>
+                      </a:r>
+                    </a:p>
+                  </a:txBody>
+                  <a:tcPr>
+                    <a:solidFill>
+                      <a:srgbClr val="2C3E50"/>
+                    </a:solidFill>
+                  </a:tcPr>
+                </a:tc>
+                <a:tc>
+                  <a:txBody>
+                    <a:bodyPr/>
+                    <a:lstStyle/>
+                    <a:p>
+                      <a:pPr algn="ctr"/>
+                      <a:r>
+                        <a:rPr sz="1400" b="1">
+                          <a:solidFill>
+                            <a:srgbClr val="FFFFFF"/>
+                          </a:solidFill>
+                          <a:latin typeface="맑은 고딕"/>
+                        </a:rPr>
+                        <a:t>98.0</a:t>
+                      </a:r>
+                    </a:p>
+                  </a:txBody>
+                  <a:tcPr>
+                    <a:solidFill>
+                      <a:srgbClr val="2C3E50"/>
+                    </a:solidFill>
+                  </a:tcPr>
+                </a:tc>
+                <a:tc>
+                  <a:txBody>
+                    <a:bodyPr/>
+                    <a:lstStyle/>
+                    <a:p>
+                      <a:pPr algn="ctr"/>
+                      <a:r>
+                        <a:rPr sz="1400" b="1">
+                          <a:solidFill>
+                            <a:srgbClr val="FFFFFF"/>
+                          </a:solidFill>
+                          <a:latin typeface="맑은 고딕"/>
+                        </a:rPr>
+                        <a:t>98.0</a:t>
+                      </a:r>
+                    </a:p>
+                  </a:txBody>
+                  <a:tcPr>
+                    <a:solidFill>
+                      <a:srgbClr val="2C3E50"/>
+                    </a:solidFill>
+                  </a:tcPr>
+                </a:tc>
+              </a:tr>
+            </a:tbl>
+          </a:graphicData>
+        </a:graphic>
+      </p:graphicFrame>
+      <p:sp>
+        <p:nvSpPr>
+          <p:cNvPr id="5" name="TextBox 4"/>
+          <p:cNvSpPr txBox="1"/>
+          <p:nvPr/>
+        </p:nvSpPr>
+        <p:spPr>
+          <a:xfrm>
+            <a:off x="457200" y="6400800"/>
+            <a:ext cx="11277295" cy="457200"/>
+          </a:xfrm>
+          <a:prstGeom prst="rect">
+            <a:avLst/>
+          </a:prstGeom>
+          <a:noFill/>
+        </p:spPr>
+        <p:txBody>
+          <a:bodyPr wrap="square">
+            <a:spAutoFit/>
+          </a:bodyPr>
+          <a:lstStyle/>
+          <a:p>
+            <a:pPr algn="ctr"/>
+            <a:r>
+              <a:rPr sz="1300" b="0" i="1">
+                <a:solidFill>
+                  <a:srgbClr val="2C3E50"/>
+                </a:solidFill>
+                <a:latin typeface="맑은 고딕"/>
+              </a:rPr>
+              <a:t>Top-4: 예측 확률 상위 4개 안에 정답 포함 비율  |  LR/MLP 77d Overall 92% = 고빈도 4클래스에 의한 착시</a:t>
+            </a:r>
+          </a:p>
+        </p:txBody>
+      </p:sp>
+    </p:spTree>
+  </p:cSld>
+  <p:clrMapOvr>
+    <a:masterClrMapping/>
+  </p:clrMapOvr>
+</p:sld>
+</file>
+
+<file path=ppt/slides/slide6.xml><?xml version="1.0" encoding="utf-8"?>
+<p:sld xmlns:a="http://schemas.openxmlformats.org/drawingml/2006/main" xmlns:p="http://schemas.openxmlformats.org/presentationml/2006/main" xmlns:r="http://schemas.openxmlformats.org/officeDocument/2006/relationships">
+  <p:cSld>
+    <p:spTree>
+      <p:nvGrpSpPr>
+        <p:cNvPr id="1" name=""/>
+        <p:cNvGrpSpPr/>
+        <p:nvPr/>
+      </p:nvGrpSpPr>
+      <p:grpSpPr/>
+      <p:sp>
+        <p:nvSpPr>
+          <p:cNvPr id="2" name="Rectangle 1"/>
+          <p:cNvSpPr/>
+          <p:nvPr/>
+        </p:nvSpPr>
+        <p:spPr>
+          <a:xfrm>
+            <a:off x="0" y="0"/>
+            <a:ext cx="12191695" cy="914400"/>
+          </a:xfrm>
+          <a:prstGeom prst="rect">
+            <a:avLst/>
+          </a:prstGeom>
+          <a:solidFill>
+            <a:srgbClr val="2C3E50"/>
+          </a:solidFill>
+          <a:ln>
+            <a:noFill/>
+          </a:ln>
+        </p:spPr>
+        <p:style>
+          <a:lnRef idx="1">
+            <a:schemeClr val="accent1"/>
+          </a:lnRef>
+          <a:fillRef idx="3">
+            <a:schemeClr val="accent1"/>
+          </a:fillRef>
+          <a:effectRef idx="2">
+            <a:schemeClr val="accent1"/>
+          </a:effectRef>
+          <a:fontRef idx="minor">
+            <a:schemeClr val="lt1"/>
+          </a:fontRef>
+        </p:style>
+        <p:txBody>
+          <a:bodyPr rtlCol="0" anchor="ctr"/>
+          <a:lstStyle/>
+          <a:p>
+            <a:pPr algn="ctr"/>
+          </a:p>
+        </p:txBody>
+      </p:sp>
+      <p:sp>
+        <p:nvSpPr>
+          <p:cNvPr id="3" name="TextBox 2"/>
+          <p:cNvSpPr txBox="1"/>
+          <p:nvPr/>
+        </p:nvSpPr>
+        <p:spPr>
+          <a:xfrm>
+            <a:off x="457200" y="91440"/>
+            <a:ext cx="11277295" cy="731520"/>
+          </a:xfrm>
+          <a:prstGeom prst="rect">
+            <a:avLst/>
+          </a:prstGeom>
+          <a:noFill/>
+        </p:spPr>
+        <p:txBody>
+          <a:bodyPr wrap="square">
+            <a:spAutoFit/>
+          </a:bodyPr>
+          <a:lstStyle/>
+          <a:p>
+            <a:pPr algn="l"/>
+            <a:r>
+              <a:rPr sz="2800" b="1">
+                <a:solidFill>
+                  <a:srgbClr val="FFFFFF"/>
+                </a:solidFill>
+                <a:latin typeface="맑은 고딕"/>
+              </a:rPr>
               <a:t>Top-4 Precision: Per-class 분석</a:t>
             </a:r>
           </a:p>
@@ -7607,7 +10003,7 @@
 </p:sld>
 </file>
 
-<file path=ppt/slides/slide6.xml><?xml version="1.0" encoding="utf-8"?>
+<file path=ppt/slides/slide7.xml><?xml version="1.0" encoding="utf-8"?>
 <p:sld xmlns:a="http://schemas.openxmlformats.org/drawingml/2006/main" xmlns:p="http://schemas.openxmlformats.org/presentationml/2006/main" xmlns:r="http://schemas.openxmlformats.org/officeDocument/2006/relationships">
   <p:cSld>
     <p:spTree>

</xml_diff>

<commit_message>
PPT slide 2: fill MLP 135d Top-3 (94.8%) and CE (0.926)
Co-Authored-By: Claude Opus 4.6 (1M context) <noreply@anthropic.com>
</commit_message>
<xml_diff>
--- a/outputs/presentations/10class_comparison.pptx
+++ b/outputs/presentations/10class_comparison.pptx
@@ -4124,7 +4124,7 @@
                           </a:solidFill>
                           <a:latin typeface="맑은 고딕"/>
                         </a:rPr>
-                        <a:t>—</a:t>
+                        <a:t>94.8%</a:t>
                       </a:r>
                     </a:p>
                   </a:txBody>
@@ -4147,7 +4147,7 @@
                           </a:solidFill>
                           <a:latin typeface="맑은 고딕"/>
                         </a:rPr>
-                        <a:t>—</a:t>
+                        <a:t>0.926</a:t>
                       </a:r>
                     </a:p>
                   </a:txBody>

</xml_diff>

<commit_message>
Fix 52d→58d, add MLP 135d metrics to slide 2 narration
- PPT slides 3, 7: "Arsenal 52d" → "Context 58d"
- Narration slide 2: add Top-3 94.8%, CE 0.926 for MLP 135d
- Narration Q&A: 52d → 58d (UMAP 5d + cluster 1d + arsenal 52d = 58d)

Co-Authored-By: Claude Opus 4.6 (1M context) <noreply@anthropic.com>
</commit_message>
<xml_diff>
--- a/outputs/presentations/10class_comparison.pptx
+++ b/outputs/presentations/10class_comparison.pptx
@@ -5184,7 +5184,7 @@
                 </a:solidFill>
                 <a:latin typeface="맑은 고딕"/>
               </a:rPr>
-              <a:t>Arsenal 52d → 41.1% → 67.6%</a:t>
+              <a:t>Context 58d → 41.1% → 67.6%</a:t>
             </a:r>
           </a:p>
           <a:p>
@@ -10293,7 +10293,7 @@
                 </a:solidFill>
                 <a:latin typeface="맑은 고딕"/>
               </a:rPr>
-              <a:t>② Arsenal 52d 추가로 +26.5pp 돌파</a:t>
+              <a:t>② Context 58d 추가로 +26.5pp 돌파</a:t>
             </a:r>
           </a:p>
         </p:txBody>

</xml_diff>

<commit_message>
PPT slide 5: show Overall Top-4 to 2 decimal places
LR 92.05%, LGB 65.95%, MLP77d 92.06%,
MLP135d 97.98%, RNN 97.97%, Transformer 98.00%

Co-Authored-By: Claude Opus 4.6 (1M context) <noreply@anthropic.com>
</commit_message>
<xml_diff>
--- a/outputs/presentations/10class_comparison.pptx
+++ b/outputs/presentations/10class_comparison.pptx
@@ -9675,7 +9675,7 @@
                           </a:solidFill>
                           <a:latin typeface="맑은 고딕"/>
                         </a:rPr>
-                        <a:t>92.1</a:t>
+                        <a:t>92.05</a:t>
                       </a:r>
                     </a:p>
                   </a:txBody>
@@ -9698,7 +9698,7 @@
                           </a:solidFill>
                           <a:latin typeface="맑은 고딕"/>
                         </a:rPr>
-                        <a:t>66.0</a:t>
+                        <a:t>65.95</a:t>
                       </a:r>
                     </a:p>
                   </a:txBody>
@@ -9721,7 +9721,7 @@
                           </a:solidFill>
                           <a:latin typeface="맑은 고딕"/>
                         </a:rPr>
-                        <a:t>92.1</a:t>
+                        <a:t>92.06</a:t>
                       </a:r>
                     </a:p>
                   </a:txBody>
@@ -9744,7 +9744,7 @@
                           </a:solidFill>
                           <a:latin typeface="맑은 고딕"/>
                         </a:rPr>
-                        <a:t>98.0</a:t>
+                        <a:t>97.98</a:t>
                       </a:r>
                     </a:p>
                   </a:txBody>
@@ -9767,7 +9767,7 @@
                           </a:solidFill>
                           <a:latin typeface="맑은 고딕"/>
                         </a:rPr>
-                        <a:t>98.0</a:t>
+                        <a:t>97.97</a:t>
                       </a:r>
                     </a:p>
                   </a:txBody>
@@ -9790,7 +9790,7 @@
                           </a:solidFill>
                           <a:latin typeface="맑은 고딕"/>
                         </a:rPr>
-                        <a:t>98.0</a:t>
+                        <a:t>98.00</a:t>
                       </a:r>
                     </a:p>
                   </a:txBody>

</xml_diff>